<commit_message>
Add Spanish pitch deck, translation guide, fundraising materials, and marketing updates
- decks/: Spanish pitch deck (PDF + PPTX), translation guide for ES/AR,
  updated commercial pitch deck, text exports, screenshot
- internal/cpanel/: Spanish pitch deck web page
- internal/fundraising/: Texeira folder, Fincap yield provider proposal PDF
- internal/marketing/: content hooks doc + index update

Co-Authored-By: Claude Sonnet 4.6 <noreply@anthropic.com>
</commit_message>
<xml_diff>
--- a/commercial-pitch-deck.pptx
+++ b/commercial-pitch-deck.pptx
@@ -2010,7 +2010,7 @@
   <p:cSld>
     <p:spTree>
       <p:nvGrpSpPr>
-        <p:cNvPr id="518" name="Shape 518"/>
+        <p:cNvPr id="520" name="Shape 520"/>
         <p:cNvGrpSpPr/>
         <p:nvPr/>
       </p:nvGrpSpPr>
@@ -2024,7 +2024,7 @@
       </p:grpSpPr>
       <p:sp>
         <p:nvSpPr>
-          <p:cNvPr id="519" name="Google Shape;519;p13:notes"/>
+          <p:cNvPr id="521" name="Google Shape;521;p13:notes"/>
           <p:cNvSpPr/>
           <p:nvPr>
             <p:ph idx="2" type="sldImg"/>
@@ -2069,7 +2069,7 @@
       </p:sp>
       <p:sp>
         <p:nvSpPr>
-          <p:cNvPr id="520" name="Google Shape;520;p13:notes"/>
+          <p:cNvPr id="522" name="Google Shape;522;p13:notes"/>
           <p:cNvSpPr txBox="1"/>
           <p:nvPr>
             <p:ph idx="1" type="body"/>
@@ -2112,7 +2112,7 @@
       </p:sp>
       <p:sp>
         <p:nvSpPr>
-          <p:cNvPr id="521" name="Google Shape;521;p13:notes"/>
+          <p:cNvPr id="523" name="Google Shape;523;p13:notes"/>
           <p:cNvSpPr txBox="1"/>
           <p:nvPr>
             <p:ph idx="12" type="sldNum"/>
@@ -2167,7 +2167,7 @@
   <p:cSld>
     <p:spTree>
       <p:nvGrpSpPr>
-        <p:cNvPr id="561" name="Shape 561"/>
+        <p:cNvPr id="563" name="Shape 563"/>
         <p:cNvGrpSpPr/>
         <p:nvPr/>
       </p:nvGrpSpPr>
@@ -2181,7 +2181,7 @@
       </p:grpSpPr>
       <p:sp>
         <p:nvSpPr>
-          <p:cNvPr id="562" name="Google Shape;562;p14:notes"/>
+          <p:cNvPr id="564" name="Google Shape;564;p14:notes"/>
           <p:cNvSpPr/>
           <p:nvPr>
             <p:ph idx="2" type="sldImg"/>
@@ -2226,7 +2226,7 @@
       </p:sp>
       <p:sp>
         <p:nvSpPr>
-          <p:cNvPr id="563" name="Google Shape;563;p14:notes"/>
+          <p:cNvPr id="565" name="Google Shape;565;p14:notes"/>
           <p:cNvSpPr txBox="1"/>
           <p:nvPr>
             <p:ph idx="1" type="body"/>
@@ -2269,7 +2269,7 @@
       </p:sp>
       <p:sp>
         <p:nvSpPr>
-          <p:cNvPr id="564" name="Google Shape;564;p14:notes"/>
+          <p:cNvPr id="566" name="Google Shape;566;p14:notes"/>
           <p:cNvSpPr txBox="1"/>
           <p:nvPr>
             <p:ph idx="12" type="sldNum"/>
@@ -2324,7 +2324,7 @@
   <p:cSld>
     <p:spTree>
       <p:nvGrpSpPr>
-        <p:cNvPr id="608" name="Shape 608"/>
+        <p:cNvPr id="610" name="Shape 610"/>
         <p:cNvGrpSpPr/>
         <p:nvPr/>
       </p:nvGrpSpPr>
@@ -2338,7 +2338,7 @@
       </p:grpSpPr>
       <p:sp>
         <p:nvSpPr>
-          <p:cNvPr id="609" name="Google Shape;609;p15:notes"/>
+          <p:cNvPr id="611" name="Google Shape;611;p15:notes"/>
           <p:cNvSpPr/>
           <p:nvPr>
             <p:ph idx="2" type="sldImg"/>
@@ -2383,7 +2383,7 @@
       </p:sp>
       <p:sp>
         <p:nvSpPr>
-          <p:cNvPr id="610" name="Google Shape;610;p15:notes"/>
+          <p:cNvPr id="612" name="Google Shape;612;p15:notes"/>
           <p:cNvSpPr txBox="1"/>
           <p:nvPr>
             <p:ph idx="1" type="body"/>
@@ -2426,7 +2426,7 @@
       </p:sp>
       <p:sp>
         <p:nvSpPr>
-          <p:cNvPr id="611" name="Google Shape;611;p15:notes"/>
+          <p:cNvPr id="613" name="Google Shape;613;p15:notes"/>
           <p:cNvSpPr txBox="1"/>
           <p:nvPr>
             <p:ph idx="12" type="sldNum"/>
@@ -12985,7 +12985,7 @@
             <a:r>
               <a:t/>
             </a:r>
-            <a:endParaRPr sz="2649"/>
+            <a:endParaRPr sz="2650"/>
           </a:p>
         </p:txBody>
       </p:sp>
@@ -13056,7 +13056,7 @@
                 <a:cs typeface="Nunito Sans"/>
                 <a:sym typeface="Nunito Sans"/>
               </a:rPr>
-              <a:t>CGO/Co-founder</a:t>
+              <a:t>CGO/Advisor</a:t>
             </a:r>
             <a:endParaRPr b="1" sz="1226">
               <a:solidFill>
@@ -13301,7 +13301,7 @@
                 <a:cs typeface="Nunito Sans"/>
                 <a:sym typeface="Nunito Sans"/>
               </a:rPr>
-              <a:t>CTO</a:t>
+              <a:t>Head of Tech</a:t>
             </a:r>
             <a:endParaRPr b="1" sz="1226">
               <a:solidFill>
@@ -13438,7 +13438,7 @@
         </p:blipFill>
         <p:spPr>
           <a:xfrm>
-            <a:off x="4558544" y="2840075"/>
+            <a:off x="4558544" y="2614088"/>
             <a:ext cx="1347000" cy="1333200"/>
           </a:xfrm>
           <a:prstGeom prst="ellipse">
@@ -13465,7 +13465,7 @@
         </p:blipFill>
         <p:spPr>
           <a:xfrm>
-            <a:off x="6141330" y="3002967"/>
+            <a:off x="6141330" y="2776992"/>
             <a:ext cx="1198200" cy="1170300"/>
           </a:xfrm>
           <a:prstGeom prst="ellipse">
@@ -13477,6 +13477,171 @@
           </a:ln>
         </p:spPr>
       </p:pic>
+      <p:sp>
+        <p:nvSpPr>
+          <p:cNvPr id="518" name="Google Shape;518;p26"/>
+          <p:cNvSpPr txBox="1"/>
+          <p:nvPr/>
+        </p:nvSpPr>
+        <p:spPr>
+          <a:xfrm>
+            <a:off x="4600250" y="4083350"/>
+            <a:ext cx="1198200" cy="400500"/>
+          </a:xfrm>
+          <a:prstGeom prst="rect">
+            <a:avLst/>
+          </a:prstGeom>
+          <a:noFill/>
+          <a:ln>
+            <a:noFill/>
+          </a:ln>
+        </p:spPr>
+        <p:txBody>
+          <a:bodyPr anchorCtr="0" anchor="t" bIns="41750" lIns="41750" spcFirstLastPara="1" rIns="41750" wrap="square" tIns="41750">
+            <a:noAutofit/>
+          </a:bodyPr>
+          <a:lstStyle/>
+          <a:p>
+            <a:pPr indent="0" lvl="0" marL="0" marR="0" rtl="0" algn="ctr">
+              <a:lnSpc>
+                <a:spcPct val="100000"/>
+              </a:lnSpc>
+              <a:spcBef>
+                <a:spcPts val="0"/>
+              </a:spcBef>
+              <a:spcAft>
+                <a:spcPts val="0"/>
+              </a:spcAft>
+              <a:buNone/>
+            </a:pPr>
+            <a:r>
+              <a:rPr b="1" lang="en-US" sz="1200">
+                <a:solidFill>
+                  <a:srgbClr val="FFFFFF"/>
+                </a:solidFill>
+                <a:latin typeface="Nunito Sans"/>
+                <a:ea typeface="Nunito Sans"/>
+                <a:cs typeface="Nunito Sans"/>
+                <a:sym typeface="Nunito Sans"/>
+              </a:rPr>
+              <a:t>Elias Nartey</a:t>
+            </a:r>
+            <a:br>
+              <a:rPr b="1" lang="en-US" sz="1200">
+                <a:solidFill>
+                  <a:srgbClr val="FFFFFF"/>
+                </a:solidFill>
+                <a:latin typeface="Nunito Sans"/>
+                <a:ea typeface="Nunito Sans"/>
+                <a:cs typeface="Nunito Sans"/>
+                <a:sym typeface="Nunito Sans"/>
+              </a:rPr>
+            </a:br>
+            <a:r>
+              <a:rPr b="1" lang="en-US" sz="1200">
+                <a:solidFill>
+                  <a:srgbClr val="FFFFFF"/>
+                </a:solidFill>
+                <a:latin typeface="Nunito Sans"/>
+                <a:ea typeface="Nunito Sans"/>
+                <a:cs typeface="Nunito Sans"/>
+                <a:sym typeface="Nunito Sans"/>
+              </a:rPr>
+              <a:t>PR- Ghana  </a:t>
+            </a:r>
+            <a:endParaRPr b="1" sz="1200">
+              <a:solidFill>
+                <a:srgbClr val="FFFFFF"/>
+              </a:solidFill>
+              <a:latin typeface="Nunito Sans"/>
+              <a:ea typeface="Nunito Sans"/>
+              <a:cs typeface="Nunito Sans"/>
+              <a:sym typeface="Nunito Sans"/>
+            </a:endParaRPr>
+          </a:p>
+        </p:txBody>
+      </p:sp>
+      <p:sp>
+        <p:nvSpPr>
+          <p:cNvPr id="519" name="Google Shape;519;p26"/>
+          <p:cNvSpPr txBox="1"/>
+          <p:nvPr/>
+        </p:nvSpPr>
+        <p:spPr>
+          <a:xfrm>
+            <a:off x="6127175" y="4018225"/>
+            <a:ext cx="1347000" cy="400500"/>
+          </a:xfrm>
+          <a:prstGeom prst="rect">
+            <a:avLst/>
+          </a:prstGeom>
+          <a:noFill/>
+          <a:ln>
+            <a:noFill/>
+          </a:ln>
+        </p:spPr>
+        <p:txBody>
+          <a:bodyPr anchorCtr="0" anchor="t" bIns="41750" lIns="41750" spcFirstLastPara="1" rIns="41750" wrap="square" tIns="41750">
+            <a:noAutofit/>
+          </a:bodyPr>
+          <a:lstStyle/>
+          <a:p>
+            <a:pPr indent="0" lvl="0" marL="0" rtl="0" algn="ctr">
+              <a:spcBef>
+                <a:spcPts val="0"/>
+              </a:spcBef>
+              <a:spcAft>
+                <a:spcPts val="0"/>
+              </a:spcAft>
+              <a:buNone/>
+            </a:pPr>
+            <a:r>
+              <a:rPr b="1" lang="en-US" sz="1248">
+                <a:solidFill>
+                  <a:srgbClr val="FFFFFF"/>
+                </a:solidFill>
+                <a:latin typeface="Nunito Sans"/>
+                <a:ea typeface="Nunito Sans"/>
+                <a:cs typeface="Nunito Sans"/>
+                <a:sym typeface="Nunito Sans"/>
+              </a:rPr>
+              <a:t>Mustafa Alhamare</a:t>
+            </a:r>
+            <a:br>
+              <a:rPr b="1" lang="en-US" sz="1248">
+                <a:solidFill>
+                  <a:srgbClr val="FFFFFF"/>
+                </a:solidFill>
+                <a:latin typeface="Nunito Sans"/>
+                <a:ea typeface="Nunito Sans"/>
+                <a:cs typeface="Nunito Sans"/>
+                <a:sym typeface="Nunito Sans"/>
+              </a:rPr>
+            </a:br>
+            <a:r>
+              <a:rPr b="1" lang="en-US" sz="1248">
+                <a:solidFill>
+                  <a:srgbClr val="FFFFFF"/>
+                </a:solidFill>
+                <a:latin typeface="Nunito Sans"/>
+                <a:ea typeface="Nunito Sans"/>
+                <a:cs typeface="Nunito Sans"/>
+                <a:sym typeface="Nunito Sans"/>
+              </a:rPr>
+              <a:t>Manager Sudan</a:t>
+            </a:r>
+            <a:endParaRPr b="1" sz="1248">
+              <a:solidFill>
+                <a:srgbClr val="FFFFFF"/>
+              </a:solidFill>
+              <a:latin typeface="Nunito Sans"/>
+              <a:ea typeface="Nunito Sans"/>
+              <a:cs typeface="Nunito Sans"/>
+              <a:sym typeface="Nunito Sans"/>
+            </a:endParaRPr>
+          </a:p>
+        </p:txBody>
+      </p:sp>
     </p:spTree>
   </p:cSld>
   <p:clrMapOvr>
@@ -13497,7 +13662,7 @@
     </p:bg>
     <p:spTree>
       <p:nvGrpSpPr>
-        <p:cNvPr id="522" name="Shape 522"/>
+        <p:cNvPr id="524" name="Shape 524"/>
         <p:cNvGrpSpPr/>
         <p:nvPr/>
       </p:nvGrpSpPr>
@@ -13511,7 +13676,7 @@
       </p:grpSpPr>
       <p:sp>
         <p:nvSpPr>
-          <p:cNvPr id="523" name="Google Shape;523;p27"/>
+          <p:cNvPr id="525" name="Google Shape;525;p27"/>
           <p:cNvSpPr/>
           <p:nvPr/>
         </p:nvSpPr>
@@ -13554,7 +13719,7 @@
       </p:sp>
       <p:sp>
         <p:nvSpPr>
-          <p:cNvPr id="524" name="Google Shape;524;p27"/>
+          <p:cNvPr id="526" name="Google Shape;526;p27"/>
           <p:cNvSpPr/>
           <p:nvPr/>
         </p:nvSpPr>
@@ -13617,7 +13782,7 @@
       </p:sp>
       <p:sp>
         <p:nvSpPr>
-          <p:cNvPr id="525" name="Google Shape;525;p27"/>
+          <p:cNvPr id="527" name="Google Shape;527;p27"/>
           <p:cNvSpPr/>
           <p:nvPr/>
         </p:nvSpPr>
@@ -13667,7 +13832,7 @@
       </p:sp>
       <p:sp>
         <p:nvSpPr>
-          <p:cNvPr id="526" name="Google Shape;526;p27"/>
+          <p:cNvPr id="528" name="Google Shape;528;p27"/>
           <p:cNvSpPr/>
           <p:nvPr/>
         </p:nvSpPr>
@@ -13710,7 +13875,7 @@
       </p:sp>
       <p:sp>
         <p:nvSpPr>
-          <p:cNvPr id="527" name="Google Shape;527;p27"/>
+          <p:cNvPr id="529" name="Google Shape;529;p27"/>
           <p:cNvSpPr/>
           <p:nvPr/>
         </p:nvSpPr>
@@ -13773,7 +13938,7 @@
       </p:sp>
       <p:sp>
         <p:nvSpPr>
-          <p:cNvPr id="528" name="Google Shape;528;p27"/>
+          <p:cNvPr id="530" name="Google Shape;530;p27"/>
           <p:cNvSpPr/>
           <p:nvPr/>
         </p:nvSpPr>
@@ -13836,7 +14001,7 @@
       </p:sp>
       <p:pic>
         <p:nvPicPr>
-          <p:cNvPr descr="preencoded.png" id="529" name="Google Shape;529;p27"/>
+          <p:cNvPr descr="preencoded.png" id="531" name="Google Shape;531;p27"/>
           <p:cNvPicPr preferRelativeResize="0"/>
           <p:nvPr/>
         </p:nvPicPr>
@@ -13863,7 +14028,7 @@
       </p:pic>
       <p:sp>
         <p:nvSpPr>
-          <p:cNvPr id="530" name="Google Shape;530;p27"/>
+          <p:cNvPr id="532" name="Google Shape;532;p27"/>
           <p:cNvSpPr/>
           <p:nvPr/>
         </p:nvSpPr>
@@ -13926,7 +14091,7 @@
       </p:sp>
       <p:pic>
         <p:nvPicPr>
-          <p:cNvPr descr="preencoded.png" id="531" name="Google Shape;531;p27"/>
+          <p:cNvPr descr="preencoded.png" id="533" name="Google Shape;533;p27"/>
           <p:cNvPicPr preferRelativeResize="0"/>
           <p:nvPr/>
         </p:nvPicPr>
@@ -13953,7 +14118,7 @@
       </p:pic>
       <p:sp>
         <p:nvSpPr>
-          <p:cNvPr id="532" name="Google Shape;532;p27"/>
+          <p:cNvPr id="534" name="Google Shape;534;p27"/>
           <p:cNvSpPr/>
           <p:nvPr/>
         </p:nvSpPr>
@@ -14016,7 +14181,7 @@
       </p:sp>
       <p:pic>
         <p:nvPicPr>
-          <p:cNvPr descr="preencoded.png" id="533" name="Google Shape;533;p27"/>
+          <p:cNvPr descr="preencoded.png" id="535" name="Google Shape;535;p27"/>
           <p:cNvPicPr preferRelativeResize="0"/>
           <p:nvPr/>
         </p:nvPicPr>
@@ -14043,7 +14208,7 @@
       </p:pic>
       <p:sp>
         <p:nvSpPr>
-          <p:cNvPr id="534" name="Google Shape;534;p27"/>
+          <p:cNvPr id="536" name="Google Shape;536;p27"/>
           <p:cNvSpPr/>
           <p:nvPr/>
         </p:nvSpPr>
@@ -14106,7 +14271,7 @@
       </p:sp>
       <p:pic>
         <p:nvPicPr>
-          <p:cNvPr descr="preencoded.png" id="535" name="Google Shape;535;p27"/>
+          <p:cNvPr descr="preencoded.png" id="537" name="Google Shape;537;p27"/>
           <p:cNvPicPr preferRelativeResize="0"/>
           <p:nvPr/>
         </p:nvPicPr>
@@ -14133,7 +14298,7 @@
       </p:pic>
       <p:sp>
         <p:nvSpPr>
-          <p:cNvPr id="536" name="Google Shape;536;p27"/>
+          <p:cNvPr id="538" name="Google Shape;538;p27"/>
           <p:cNvSpPr/>
           <p:nvPr/>
         </p:nvSpPr>
@@ -14196,7 +14361,7 @@
       </p:sp>
       <p:sp>
         <p:nvSpPr>
-          <p:cNvPr id="537" name="Google Shape;537;p27"/>
+          <p:cNvPr id="539" name="Google Shape;539;p27"/>
           <p:cNvSpPr/>
           <p:nvPr/>
         </p:nvSpPr>
@@ -14246,7 +14411,7 @@
       </p:sp>
       <p:sp>
         <p:nvSpPr>
-          <p:cNvPr id="538" name="Google Shape;538;p27"/>
+          <p:cNvPr id="540" name="Google Shape;540;p27"/>
           <p:cNvSpPr/>
           <p:nvPr/>
         </p:nvSpPr>
@@ -14289,7 +14454,7 @@
       </p:sp>
       <p:sp>
         <p:nvSpPr>
-          <p:cNvPr id="539" name="Google Shape;539;p27"/>
+          <p:cNvPr id="541" name="Google Shape;541;p27"/>
           <p:cNvSpPr/>
           <p:nvPr/>
         </p:nvSpPr>
@@ -14352,7 +14517,7 @@
       </p:sp>
       <p:sp>
         <p:nvSpPr>
-          <p:cNvPr id="540" name="Google Shape;540;p27"/>
+          <p:cNvPr id="542" name="Google Shape;542;p27"/>
           <p:cNvSpPr/>
           <p:nvPr/>
         </p:nvSpPr>
@@ -14415,7 +14580,7 @@
       </p:sp>
       <p:pic>
         <p:nvPicPr>
-          <p:cNvPr descr="preencoded.png" id="541" name="Google Shape;541;p27"/>
+          <p:cNvPr descr="preencoded.png" id="543" name="Google Shape;543;p27"/>
           <p:cNvPicPr preferRelativeResize="0"/>
           <p:nvPr/>
         </p:nvPicPr>
@@ -14442,7 +14607,7 @@
       </p:pic>
       <p:sp>
         <p:nvSpPr>
-          <p:cNvPr id="542" name="Google Shape;542;p27"/>
+          <p:cNvPr id="544" name="Google Shape;544;p27"/>
           <p:cNvSpPr/>
           <p:nvPr/>
         </p:nvSpPr>
@@ -14505,7 +14670,7 @@
       </p:sp>
       <p:pic>
         <p:nvPicPr>
-          <p:cNvPr descr="preencoded.png" id="543" name="Google Shape;543;p27"/>
+          <p:cNvPr descr="preencoded.png" id="545" name="Google Shape;545;p27"/>
           <p:cNvPicPr preferRelativeResize="0"/>
           <p:nvPr/>
         </p:nvPicPr>
@@ -14532,7 +14697,7 @@
       </p:pic>
       <p:sp>
         <p:nvSpPr>
-          <p:cNvPr id="544" name="Google Shape;544;p27"/>
+          <p:cNvPr id="546" name="Google Shape;546;p27"/>
           <p:cNvSpPr/>
           <p:nvPr/>
         </p:nvSpPr>
@@ -14595,7 +14760,7 @@
       </p:sp>
       <p:pic>
         <p:nvPicPr>
-          <p:cNvPr descr="preencoded.png" id="545" name="Google Shape;545;p27"/>
+          <p:cNvPr descr="preencoded.png" id="547" name="Google Shape;547;p27"/>
           <p:cNvPicPr preferRelativeResize="0"/>
           <p:nvPr/>
         </p:nvPicPr>
@@ -14622,7 +14787,7 @@
       </p:pic>
       <p:sp>
         <p:nvSpPr>
-          <p:cNvPr id="546" name="Google Shape;546;p27"/>
+          <p:cNvPr id="548" name="Google Shape;548;p27"/>
           <p:cNvSpPr/>
           <p:nvPr/>
         </p:nvSpPr>
@@ -14685,7 +14850,7 @@
       </p:sp>
       <p:pic>
         <p:nvPicPr>
-          <p:cNvPr descr="preencoded.png" id="547" name="Google Shape;547;p27"/>
+          <p:cNvPr descr="preencoded.png" id="549" name="Google Shape;549;p27"/>
           <p:cNvPicPr preferRelativeResize="0"/>
           <p:nvPr/>
         </p:nvPicPr>
@@ -14712,7 +14877,7 @@
       </p:pic>
       <p:sp>
         <p:nvSpPr>
-          <p:cNvPr id="548" name="Google Shape;548;p27"/>
+          <p:cNvPr id="550" name="Google Shape;550;p27"/>
           <p:cNvSpPr/>
           <p:nvPr/>
         </p:nvSpPr>
@@ -14775,7 +14940,7 @@
       </p:sp>
       <p:sp>
         <p:nvSpPr>
-          <p:cNvPr id="549" name="Google Shape;549;p27"/>
+          <p:cNvPr id="551" name="Google Shape;551;p27"/>
           <p:cNvSpPr/>
           <p:nvPr/>
         </p:nvSpPr>
@@ -14825,7 +14990,7 @@
       </p:sp>
       <p:sp>
         <p:nvSpPr>
-          <p:cNvPr id="550" name="Google Shape;550;p27"/>
+          <p:cNvPr id="552" name="Google Shape;552;p27"/>
           <p:cNvSpPr/>
           <p:nvPr/>
         </p:nvSpPr>
@@ -14868,7 +15033,7 @@
       </p:sp>
       <p:sp>
         <p:nvSpPr>
-          <p:cNvPr id="551" name="Google Shape;551;p27"/>
+          <p:cNvPr id="553" name="Google Shape;553;p27"/>
           <p:cNvSpPr/>
           <p:nvPr/>
         </p:nvSpPr>
@@ -14931,7 +15096,7 @@
       </p:sp>
       <p:sp>
         <p:nvSpPr>
-          <p:cNvPr id="552" name="Google Shape;552;p27"/>
+          <p:cNvPr id="554" name="Google Shape;554;p27"/>
           <p:cNvSpPr/>
           <p:nvPr/>
         </p:nvSpPr>
@@ -14994,7 +15159,7 @@
       </p:sp>
       <p:pic>
         <p:nvPicPr>
-          <p:cNvPr descr="preencoded.png" id="553" name="Google Shape;553;p27"/>
+          <p:cNvPr descr="preencoded.png" id="555" name="Google Shape;555;p27"/>
           <p:cNvPicPr preferRelativeResize="0"/>
           <p:nvPr/>
         </p:nvPicPr>
@@ -15021,7 +15186,7 @@
       </p:pic>
       <p:sp>
         <p:nvSpPr>
-          <p:cNvPr id="554" name="Google Shape;554;p27"/>
+          <p:cNvPr id="556" name="Google Shape;556;p27"/>
           <p:cNvSpPr/>
           <p:nvPr/>
         </p:nvSpPr>
@@ -15084,7 +15249,7 @@
       </p:sp>
       <p:pic>
         <p:nvPicPr>
-          <p:cNvPr descr="preencoded.png" id="555" name="Google Shape;555;p27"/>
+          <p:cNvPr descr="preencoded.png" id="557" name="Google Shape;557;p27"/>
           <p:cNvPicPr preferRelativeResize="0"/>
           <p:nvPr/>
         </p:nvPicPr>
@@ -15111,7 +15276,7 @@
       </p:pic>
       <p:sp>
         <p:nvSpPr>
-          <p:cNvPr id="556" name="Google Shape;556;p27"/>
+          <p:cNvPr id="558" name="Google Shape;558;p27"/>
           <p:cNvSpPr/>
           <p:nvPr/>
         </p:nvSpPr>
@@ -15174,7 +15339,7 @@
       </p:sp>
       <p:pic>
         <p:nvPicPr>
-          <p:cNvPr descr="preencoded.png" id="557" name="Google Shape;557;p27"/>
+          <p:cNvPr descr="preencoded.png" id="559" name="Google Shape;559;p27"/>
           <p:cNvPicPr preferRelativeResize="0"/>
           <p:nvPr/>
         </p:nvPicPr>
@@ -15201,7 +15366,7 @@
       </p:pic>
       <p:sp>
         <p:nvSpPr>
-          <p:cNvPr id="558" name="Google Shape;558;p27"/>
+          <p:cNvPr id="560" name="Google Shape;560;p27"/>
           <p:cNvSpPr/>
           <p:nvPr/>
         </p:nvSpPr>
@@ -15264,7 +15429,7 @@
       </p:sp>
       <p:pic>
         <p:nvPicPr>
-          <p:cNvPr descr="preencoded.png" id="559" name="Google Shape;559;p27"/>
+          <p:cNvPr descr="preencoded.png" id="561" name="Google Shape;561;p27"/>
           <p:cNvPicPr preferRelativeResize="0"/>
           <p:nvPr/>
         </p:nvPicPr>
@@ -15291,7 +15456,7 @@
       </p:pic>
       <p:sp>
         <p:nvSpPr>
-          <p:cNvPr id="560" name="Google Shape;560;p27"/>
+          <p:cNvPr id="562" name="Google Shape;562;p27"/>
           <p:cNvSpPr/>
           <p:nvPr/>
         </p:nvSpPr>
@@ -15372,7 +15537,7 @@
     </p:bg>
     <p:spTree>
       <p:nvGrpSpPr>
-        <p:cNvPr id="565" name="Shape 565"/>
+        <p:cNvPr id="567" name="Shape 567"/>
         <p:cNvGrpSpPr/>
         <p:nvPr/>
       </p:nvGrpSpPr>
@@ -15386,7 +15551,7 @@
       </p:grpSpPr>
       <p:sp>
         <p:nvSpPr>
-          <p:cNvPr id="566" name="Google Shape;566;p28"/>
+          <p:cNvPr id="568" name="Google Shape;568;p28"/>
           <p:cNvSpPr/>
           <p:nvPr/>
         </p:nvSpPr>
@@ -15429,7 +15594,7 @@
       </p:sp>
       <p:sp>
         <p:nvSpPr>
-          <p:cNvPr id="567" name="Google Shape;567;p28"/>
+          <p:cNvPr id="569" name="Google Shape;569;p28"/>
           <p:cNvSpPr/>
           <p:nvPr/>
         </p:nvSpPr>
@@ -15492,7 +15657,7 @@
       </p:sp>
       <p:sp>
         <p:nvSpPr>
-          <p:cNvPr id="568" name="Google Shape;568;p28"/>
+          <p:cNvPr id="570" name="Google Shape;570;p28"/>
           <p:cNvSpPr/>
           <p:nvPr/>
         </p:nvSpPr>
@@ -15535,7 +15700,7 @@
       </p:sp>
       <p:sp>
         <p:nvSpPr>
-          <p:cNvPr id="569" name="Google Shape;569;p28"/>
+          <p:cNvPr id="571" name="Google Shape;571;p28"/>
           <p:cNvSpPr/>
           <p:nvPr/>
         </p:nvSpPr>
@@ -15598,7 +15763,7 @@
       </p:sp>
       <p:sp>
         <p:nvSpPr>
-          <p:cNvPr id="570" name="Google Shape;570;p28"/>
+          <p:cNvPr id="572" name="Google Shape;572;p28"/>
           <p:cNvSpPr/>
           <p:nvPr/>
         </p:nvSpPr>
@@ -15645,7 +15810,27 @@
                 <a:cs typeface="Arial"/>
                 <a:sym typeface="Arial"/>
               </a:rPr>
-              <a:t>$2M Target  |  $15M Pre-Money Valuation</a:t>
+              <a:t>$</a:t>
+            </a:r>
+            <a:r>
+              <a:rPr b="1" lang="en-US" sz="1200">
+                <a:solidFill>
+                  <a:srgbClr val="FFFFFF"/>
+                </a:solidFill>
+              </a:rPr>
+              <a:t>3</a:t>
+            </a:r>
+            <a:r>
+              <a:rPr b="1" i="0" lang="en-US" sz="1200" u="none" cap="none" strike="noStrike">
+                <a:solidFill>
+                  <a:srgbClr val="FFFFFF"/>
+                </a:solidFill>
+                <a:latin typeface="Arial"/>
+                <a:ea typeface="Arial"/>
+                <a:cs typeface="Arial"/>
+                <a:sym typeface="Arial"/>
+              </a:rPr>
+              <a:t>M Target  |  $15M Pre-Money Valuation</a:t>
             </a:r>
             <a:endParaRPr b="0" i="0" sz="1200" u="none" cap="none" strike="noStrike">
               <a:solidFill>
@@ -15661,7 +15846,7 @@
       </p:sp>
       <p:sp>
         <p:nvSpPr>
-          <p:cNvPr id="571" name="Google Shape;571;p28"/>
+          <p:cNvPr id="573" name="Google Shape;573;p28"/>
           <p:cNvSpPr/>
           <p:nvPr/>
         </p:nvSpPr>
@@ -15724,7 +15909,7 @@
       </p:sp>
       <p:sp>
         <p:nvSpPr>
-          <p:cNvPr id="572" name="Google Shape;572;p28"/>
+          <p:cNvPr id="574" name="Google Shape;574;p28"/>
           <p:cNvSpPr/>
           <p:nvPr/>
         </p:nvSpPr>
@@ -15767,7 +15952,7 @@
       </p:sp>
       <p:sp>
         <p:nvSpPr>
-          <p:cNvPr id="573" name="Google Shape;573;p28"/>
+          <p:cNvPr id="575" name="Google Shape;575;p28"/>
           <p:cNvSpPr/>
           <p:nvPr/>
         </p:nvSpPr>
@@ -15810,7 +15995,7 @@
       </p:sp>
       <p:sp>
         <p:nvSpPr>
-          <p:cNvPr id="574" name="Google Shape;574;p28"/>
+          <p:cNvPr id="576" name="Google Shape;576;p28"/>
           <p:cNvSpPr/>
           <p:nvPr/>
         </p:nvSpPr>
@@ -15853,7 +16038,7 @@
       </p:sp>
       <p:sp>
         <p:nvSpPr>
-          <p:cNvPr id="575" name="Google Shape;575;p28"/>
+          <p:cNvPr id="577" name="Google Shape;577;p28"/>
           <p:cNvSpPr/>
           <p:nvPr/>
         </p:nvSpPr>
@@ -15912,7 +16097,27 @@
                 <a:cs typeface="Arial"/>
                 <a:sym typeface="Arial"/>
               </a:rPr>
-              <a:t>Working Capital 85% ($1.7M)</a:t>
+              <a:t>Working Capital 85% ($</a:t>
+            </a:r>
+            <a:r>
+              <a:rPr lang="en-US" sz="950">
+                <a:solidFill>
+                  <a:srgbClr val="1A2332"/>
+                </a:solidFill>
+              </a:rPr>
+              <a:t>2.55</a:t>
+            </a:r>
+            <a:r>
+              <a:rPr b="0" i="0" lang="en-US" sz="950" u="none" cap="none" strike="noStrike">
+                <a:solidFill>
+                  <a:srgbClr val="1A2332"/>
+                </a:solidFill>
+                <a:latin typeface="Arial"/>
+                <a:ea typeface="Arial"/>
+                <a:cs typeface="Arial"/>
+                <a:sym typeface="Arial"/>
+              </a:rPr>
+              <a:t>M)</a:t>
             </a:r>
             <a:endParaRPr b="0" i="0" sz="1200" u="none" cap="none" strike="noStrike">
               <a:solidFill>
@@ -15928,7 +16133,7 @@
       </p:sp>
       <p:sp>
         <p:nvSpPr>
-          <p:cNvPr id="576" name="Google Shape;576;p28"/>
+          <p:cNvPr id="578" name="Google Shape;578;p28"/>
           <p:cNvSpPr/>
           <p:nvPr/>
         </p:nvSpPr>
@@ -15971,7 +16176,7 @@
       </p:sp>
       <p:sp>
         <p:nvSpPr>
-          <p:cNvPr id="577" name="Google Shape;577;p28"/>
+          <p:cNvPr id="579" name="Google Shape;579;p28"/>
           <p:cNvSpPr/>
           <p:nvPr/>
         </p:nvSpPr>
@@ -16030,7 +16235,27 @@
                 <a:cs typeface="Arial"/>
                 <a:sym typeface="Arial"/>
               </a:rPr>
-              <a:t>SG&amp;A 15% ($300K)</a:t>
+              <a:t>SG&amp;A 15% ($</a:t>
+            </a:r>
+            <a:r>
+              <a:rPr lang="en-US" sz="950">
+                <a:solidFill>
+                  <a:srgbClr val="1A2332"/>
+                </a:solidFill>
+              </a:rPr>
+              <a:t>450</a:t>
+            </a:r>
+            <a:r>
+              <a:rPr b="0" i="0" lang="en-US" sz="950" u="none" cap="none" strike="noStrike">
+                <a:solidFill>
+                  <a:srgbClr val="1A2332"/>
+                </a:solidFill>
+                <a:latin typeface="Arial"/>
+                <a:ea typeface="Arial"/>
+                <a:cs typeface="Arial"/>
+                <a:sym typeface="Arial"/>
+              </a:rPr>
+              <a:t>K)</a:t>
             </a:r>
             <a:endParaRPr b="0" i="0" sz="1200" u="none" cap="none" strike="noStrike">
               <a:solidFill>
@@ -16046,7 +16271,7 @@
       </p:sp>
       <p:sp>
         <p:nvSpPr>
-          <p:cNvPr id="578" name="Google Shape;578;p28"/>
+          <p:cNvPr id="580" name="Google Shape;580;p28"/>
           <p:cNvSpPr/>
           <p:nvPr/>
         </p:nvSpPr>
@@ -16096,7 +16321,7 @@
       </p:sp>
       <p:sp>
         <p:nvSpPr>
-          <p:cNvPr id="579" name="Google Shape;579;p28"/>
+          <p:cNvPr id="581" name="Google Shape;581;p28"/>
           <p:cNvSpPr/>
           <p:nvPr/>
         </p:nvSpPr>
@@ -16159,7 +16384,7 @@
       </p:sp>
       <p:sp>
         <p:nvSpPr>
-          <p:cNvPr id="580" name="Google Shape;580;p28"/>
+          <p:cNvPr id="582" name="Google Shape;582;p28"/>
           <p:cNvSpPr/>
           <p:nvPr/>
         </p:nvSpPr>
@@ -16202,7 +16427,7 @@
       </p:sp>
       <p:sp>
         <p:nvSpPr>
-          <p:cNvPr id="581" name="Google Shape;581;p28"/>
+          <p:cNvPr id="583" name="Google Shape;583;p28"/>
           <p:cNvSpPr/>
           <p:nvPr/>
         </p:nvSpPr>
@@ -16265,7 +16490,7 @@
       </p:sp>
       <p:sp>
         <p:nvSpPr>
-          <p:cNvPr id="582" name="Google Shape;582;p28"/>
+          <p:cNvPr id="584" name="Google Shape;584;p28"/>
           <p:cNvSpPr/>
           <p:nvPr/>
         </p:nvSpPr>
@@ -16328,7 +16553,7 @@
       </p:sp>
       <p:sp>
         <p:nvSpPr>
-          <p:cNvPr id="583" name="Google Shape;583;p28"/>
+          <p:cNvPr id="585" name="Google Shape;585;p28"/>
           <p:cNvSpPr/>
           <p:nvPr/>
         </p:nvSpPr>
@@ -16391,7 +16616,7 @@
       </p:sp>
       <p:sp>
         <p:nvSpPr>
-          <p:cNvPr id="584" name="Google Shape;584;p28"/>
+          <p:cNvPr id="586" name="Google Shape;586;p28"/>
           <p:cNvSpPr/>
           <p:nvPr/>
         </p:nvSpPr>
@@ -16454,7 +16679,7 @@
       </p:sp>
       <p:sp>
         <p:nvSpPr>
-          <p:cNvPr id="585" name="Google Shape;585;p28"/>
+          <p:cNvPr id="587" name="Google Shape;587;p28"/>
           <p:cNvSpPr/>
           <p:nvPr/>
         </p:nvSpPr>
@@ -16497,7 +16722,7 @@
       </p:sp>
       <p:sp>
         <p:nvSpPr>
-          <p:cNvPr id="586" name="Google Shape;586;p28"/>
+          <p:cNvPr id="588" name="Google Shape;588;p28"/>
           <p:cNvSpPr/>
           <p:nvPr/>
         </p:nvSpPr>
@@ -16560,7 +16785,7 @@
       </p:sp>
       <p:sp>
         <p:nvSpPr>
-          <p:cNvPr id="587" name="Google Shape;587;p28"/>
+          <p:cNvPr id="589" name="Google Shape;589;p28"/>
           <p:cNvSpPr/>
           <p:nvPr/>
         </p:nvSpPr>
@@ -16623,7 +16848,7 @@
       </p:sp>
       <p:sp>
         <p:nvSpPr>
-          <p:cNvPr id="588" name="Google Shape;588;p28"/>
+          <p:cNvPr id="590" name="Google Shape;590;p28"/>
           <p:cNvSpPr/>
           <p:nvPr/>
         </p:nvSpPr>
@@ -16686,7 +16911,7 @@
       </p:sp>
       <p:sp>
         <p:nvSpPr>
-          <p:cNvPr id="589" name="Google Shape;589;p28"/>
+          <p:cNvPr id="591" name="Google Shape;591;p28"/>
           <p:cNvSpPr/>
           <p:nvPr/>
         </p:nvSpPr>
@@ -16749,7 +16974,7 @@
       </p:sp>
       <p:sp>
         <p:nvSpPr>
-          <p:cNvPr id="590" name="Google Shape;590;p28"/>
+          <p:cNvPr id="592" name="Google Shape;592;p28"/>
           <p:cNvSpPr/>
           <p:nvPr/>
         </p:nvSpPr>
@@ -16792,7 +17017,7 @@
       </p:sp>
       <p:sp>
         <p:nvSpPr>
-          <p:cNvPr id="591" name="Google Shape;591;p28"/>
+          <p:cNvPr id="593" name="Google Shape;593;p28"/>
           <p:cNvSpPr/>
           <p:nvPr/>
         </p:nvSpPr>
@@ -16855,7 +17080,7 @@
       </p:sp>
       <p:sp>
         <p:nvSpPr>
-          <p:cNvPr id="592" name="Google Shape;592;p28"/>
+          <p:cNvPr id="594" name="Google Shape;594;p28"/>
           <p:cNvSpPr/>
           <p:nvPr/>
         </p:nvSpPr>
@@ -16918,7 +17143,7 @@
       </p:sp>
       <p:sp>
         <p:nvSpPr>
-          <p:cNvPr id="593" name="Google Shape;593;p28"/>
+          <p:cNvPr id="595" name="Google Shape;595;p28"/>
           <p:cNvSpPr/>
           <p:nvPr/>
         </p:nvSpPr>
@@ -16968,7 +17193,7 @@
       </p:sp>
       <p:sp>
         <p:nvSpPr>
-          <p:cNvPr id="594" name="Google Shape;594;p28"/>
+          <p:cNvPr id="596" name="Google Shape;596;p28"/>
           <p:cNvSpPr/>
           <p:nvPr/>
         </p:nvSpPr>
@@ -17031,7 +17256,7 @@
       </p:sp>
       <p:pic>
         <p:nvPicPr>
-          <p:cNvPr descr="preencoded.png" id="595" name="Google Shape;595;p28"/>
+          <p:cNvPr descr="preencoded.png" id="597" name="Google Shape;597;p28"/>
           <p:cNvPicPr preferRelativeResize="0"/>
           <p:nvPr/>
         </p:nvPicPr>
@@ -17058,7 +17283,7 @@
       </p:pic>
       <p:sp>
         <p:nvSpPr>
-          <p:cNvPr id="596" name="Google Shape;596;p28"/>
+          <p:cNvPr id="598" name="Google Shape;598;p28"/>
           <p:cNvSpPr/>
           <p:nvPr/>
         </p:nvSpPr>
@@ -17121,7 +17346,7 @@
       </p:sp>
       <p:pic>
         <p:nvPicPr>
-          <p:cNvPr descr="preencoded.png" id="597" name="Google Shape;597;p28"/>
+          <p:cNvPr descr="preencoded.png" id="599" name="Google Shape;599;p28"/>
           <p:cNvPicPr preferRelativeResize="0"/>
           <p:nvPr/>
         </p:nvPicPr>
@@ -17148,7 +17373,7 @@
       </p:pic>
       <p:sp>
         <p:nvSpPr>
-          <p:cNvPr id="598" name="Google Shape;598;p28"/>
+          <p:cNvPr id="600" name="Google Shape;600;p28"/>
           <p:cNvSpPr/>
           <p:nvPr/>
         </p:nvSpPr>
@@ -17211,7 +17436,7 @@
       </p:sp>
       <p:pic>
         <p:nvPicPr>
-          <p:cNvPr descr="preencoded.png" id="599" name="Google Shape;599;p28"/>
+          <p:cNvPr descr="preencoded.png" id="601" name="Google Shape;601;p28"/>
           <p:cNvPicPr preferRelativeResize="0"/>
           <p:nvPr/>
         </p:nvPicPr>
@@ -17238,7 +17463,7 @@
       </p:pic>
       <p:sp>
         <p:nvSpPr>
-          <p:cNvPr id="600" name="Google Shape;600;p28"/>
+          <p:cNvPr id="602" name="Google Shape;602;p28"/>
           <p:cNvSpPr/>
           <p:nvPr/>
         </p:nvSpPr>
@@ -17301,7 +17526,7 @@
       </p:sp>
       <p:pic>
         <p:nvPicPr>
-          <p:cNvPr descr="preencoded.png" id="601" name="Google Shape;601;p28"/>
+          <p:cNvPr descr="preencoded.png" id="603" name="Google Shape;603;p28"/>
           <p:cNvPicPr preferRelativeResize="0"/>
           <p:nvPr/>
         </p:nvPicPr>
@@ -17328,7 +17553,7 @@
       </p:pic>
       <p:sp>
         <p:nvSpPr>
-          <p:cNvPr id="602" name="Google Shape;602;p28"/>
+          <p:cNvPr id="604" name="Google Shape;604;p28"/>
           <p:cNvSpPr/>
           <p:nvPr/>
         </p:nvSpPr>
@@ -17391,7 +17616,7 @@
       </p:sp>
       <p:pic>
         <p:nvPicPr>
-          <p:cNvPr descr="preencoded.png" id="603" name="Google Shape;603;p28"/>
+          <p:cNvPr descr="preencoded.png" id="605" name="Google Shape;605;p28"/>
           <p:cNvPicPr preferRelativeResize="0"/>
           <p:nvPr/>
         </p:nvPicPr>
@@ -17418,7 +17643,7 @@
       </p:pic>
       <p:sp>
         <p:nvSpPr>
-          <p:cNvPr id="604" name="Google Shape;604;p28"/>
+          <p:cNvPr id="606" name="Google Shape;606;p28"/>
           <p:cNvSpPr/>
           <p:nvPr/>
         </p:nvSpPr>
@@ -17481,7 +17706,7 @@
       </p:sp>
       <p:sp>
         <p:nvSpPr>
-          <p:cNvPr id="605" name="Google Shape;605;p28"/>
+          <p:cNvPr id="607" name="Google Shape;607;p28"/>
           <p:cNvSpPr/>
           <p:nvPr/>
         </p:nvSpPr>
@@ -17544,7 +17769,7 @@
       </p:sp>
       <p:pic>
         <p:nvPicPr>
-          <p:cNvPr descr="preencoded.png" id="606" name="Google Shape;606;p28"/>
+          <p:cNvPr descr="preencoded.png" id="608" name="Google Shape;608;p28"/>
           <p:cNvPicPr preferRelativeResize="0"/>
           <p:nvPr/>
         </p:nvPicPr>
@@ -17571,7 +17796,7 @@
       </p:pic>
       <p:sp>
         <p:nvSpPr>
-          <p:cNvPr id="607" name="Google Shape;607;p28"/>
+          <p:cNvPr id="609" name="Google Shape;609;p28"/>
           <p:cNvSpPr/>
           <p:nvPr/>
         </p:nvSpPr>
@@ -17644,7 +17869,7 @@
     </p:bg>
     <p:spTree>
       <p:nvGrpSpPr>
-        <p:cNvPr id="612" name="Shape 612"/>
+        <p:cNvPr id="614" name="Shape 614"/>
         <p:cNvGrpSpPr/>
         <p:nvPr/>
       </p:nvGrpSpPr>
@@ -17658,7 +17883,7 @@
       </p:grpSpPr>
       <p:sp>
         <p:nvSpPr>
-          <p:cNvPr id="613" name="Google Shape;613;p29"/>
+          <p:cNvPr id="615" name="Google Shape;615;p29"/>
           <p:cNvSpPr/>
           <p:nvPr/>
         </p:nvSpPr>
@@ -17701,7 +17926,7 @@
       </p:sp>
       <p:sp>
         <p:nvSpPr>
-          <p:cNvPr id="614" name="Google Shape;614;p29"/>
+          <p:cNvPr id="616" name="Google Shape;616;p29"/>
           <p:cNvSpPr/>
           <p:nvPr/>
         </p:nvSpPr>
@@ -17764,7 +17989,7 @@
       </p:sp>
       <p:sp>
         <p:nvSpPr>
-          <p:cNvPr id="615" name="Google Shape;615;p29"/>
+          <p:cNvPr id="617" name="Google Shape;617;p29"/>
           <p:cNvSpPr/>
           <p:nvPr/>
         </p:nvSpPr>
@@ -17827,7 +18052,7 @@
       </p:sp>
       <p:sp>
         <p:nvSpPr>
-          <p:cNvPr id="616" name="Google Shape;616;p29"/>
+          <p:cNvPr id="618" name="Google Shape;618;p29"/>
           <p:cNvSpPr/>
           <p:nvPr/>
         </p:nvSpPr>
@@ -17890,7 +18115,7 @@
       </p:sp>
       <p:sp>
         <p:nvSpPr>
-          <p:cNvPr id="617" name="Google Shape;617;p29"/>
+          <p:cNvPr id="619" name="Google Shape;619;p29"/>
           <p:cNvSpPr/>
           <p:nvPr/>
         </p:nvSpPr>
@@ -17933,7 +18158,7 @@
       </p:sp>
       <p:sp>
         <p:nvSpPr>
-          <p:cNvPr id="618" name="Google Shape;618;p29"/>
+          <p:cNvPr id="620" name="Google Shape;620;p29"/>
           <p:cNvSpPr/>
           <p:nvPr/>
         </p:nvSpPr>
@@ -17996,7 +18221,7 @@
       </p:sp>
       <p:sp>
         <p:nvSpPr>
-          <p:cNvPr id="619" name="Google Shape;619;p29"/>
+          <p:cNvPr id="621" name="Google Shape;621;p29"/>
           <p:cNvSpPr/>
           <p:nvPr/>
         </p:nvSpPr>
@@ -18071,7 +18296,7 @@
       </p:sp>
       <p:sp>
         <p:nvSpPr>
-          <p:cNvPr id="620" name="Google Shape;620;p29"/>
+          <p:cNvPr id="622" name="Google Shape;622;p29"/>
           <p:cNvSpPr/>
           <p:nvPr/>
         </p:nvSpPr>
@@ -18114,7 +18339,7 @@
       </p:sp>
       <p:sp>
         <p:nvSpPr>
-          <p:cNvPr id="621" name="Google Shape;621;p29"/>
+          <p:cNvPr id="623" name="Google Shape;623;p29"/>
           <p:cNvSpPr/>
           <p:nvPr/>
         </p:nvSpPr>
@@ -18177,7 +18402,7 @@
       </p:sp>
       <p:sp>
         <p:nvSpPr>
-          <p:cNvPr id="622" name="Google Shape;622;p29"/>
+          <p:cNvPr id="624" name="Google Shape;624;p29"/>
           <p:cNvSpPr/>
           <p:nvPr/>
         </p:nvSpPr>
@@ -18252,7 +18477,7 @@
       </p:sp>
       <p:sp>
         <p:nvSpPr>
-          <p:cNvPr id="623" name="Google Shape;623;p29"/>
+          <p:cNvPr id="625" name="Google Shape;625;p29"/>
           <p:cNvSpPr/>
           <p:nvPr/>
         </p:nvSpPr>
@@ -18295,7 +18520,7 @@
       </p:sp>
       <p:sp>
         <p:nvSpPr>
-          <p:cNvPr id="624" name="Google Shape;624;p29"/>
+          <p:cNvPr id="626" name="Google Shape;626;p29"/>
           <p:cNvSpPr/>
           <p:nvPr/>
         </p:nvSpPr>
@@ -18358,7 +18583,7 @@
       </p:sp>
       <p:sp>
         <p:nvSpPr>
-          <p:cNvPr id="625" name="Google Shape;625;p29"/>
+          <p:cNvPr id="627" name="Google Shape;627;p29"/>
           <p:cNvSpPr/>
           <p:nvPr/>
         </p:nvSpPr>
@@ -18433,7 +18658,7 @@
       </p:sp>
       <p:sp>
         <p:nvSpPr>
-          <p:cNvPr id="626" name="Google Shape;626;p29"/>
+          <p:cNvPr id="628" name="Google Shape;628;p29"/>
           <p:cNvSpPr/>
           <p:nvPr/>
         </p:nvSpPr>
@@ -18476,7 +18701,7 @@
       </p:sp>
       <p:sp>
         <p:nvSpPr>
-          <p:cNvPr id="627" name="Google Shape;627;p29"/>
+          <p:cNvPr id="629" name="Google Shape;629;p29"/>
           <p:cNvSpPr/>
           <p:nvPr/>
         </p:nvSpPr>
@@ -18539,7 +18764,7 @@
       </p:sp>
       <p:sp>
         <p:nvSpPr>
-          <p:cNvPr id="628" name="Google Shape;628;p29"/>
+          <p:cNvPr id="630" name="Google Shape;630;p29"/>
           <p:cNvSpPr/>
           <p:nvPr/>
         </p:nvSpPr>
@@ -18614,7 +18839,7 @@
       </p:sp>
       <p:sp>
         <p:nvSpPr>
-          <p:cNvPr id="629" name="Google Shape;629;p29"/>
+          <p:cNvPr id="631" name="Google Shape;631;p29"/>
           <p:cNvSpPr/>
           <p:nvPr/>
         </p:nvSpPr>
@@ -18657,7 +18882,7 @@
       </p:sp>
       <p:sp>
         <p:nvSpPr>
-          <p:cNvPr id="630" name="Google Shape;630;p29"/>
+          <p:cNvPr id="632" name="Google Shape;632;p29"/>
           <p:cNvSpPr/>
           <p:nvPr/>
         </p:nvSpPr>
@@ -18720,7 +18945,7 @@
       </p:sp>
       <p:sp>
         <p:nvSpPr>
-          <p:cNvPr id="631" name="Google Shape;631;p29"/>
+          <p:cNvPr id="633" name="Google Shape;633;p29"/>
           <p:cNvSpPr/>
           <p:nvPr/>
         </p:nvSpPr>
@@ -18795,7 +19020,7 @@
       </p:sp>
       <p:cxnSp>
         <p:nvCxnSpPr>
-          <p:cNvPr id="632" name="Google Shape;632;p29"/>
+          <p:cNvPr id="634" name="Google Shape;634;p29"/>
           <p:cNvCxnSpPr/>
           <p:nvPr/>
         </p:nvCxnSpPr>
@@ -18821,7 +19046,7 @@
       </p:cxnSp>
       <p:sp>
         <p:nvSpPr>
-          <p:cNvPr id="633" name="Google Shape;633;p29"/>
+          <p:cNvPr id="635" name="Google Shape;635;p29"/>
           <p:cNvSpPr/>
           <p:nvPr/>
         </p:nvSpPr>
@@ -18884,7 +19109,7 @@
       </p:sp>
       <p:sp>
         <p:nvSpPr>
-          <p:cNvPr id="634" name="Google Shape;634;p29"/>
+          <p:cNvPr id="636" name="Google Shape;636;p29"/>
           <p:cNvSpPr/>
           <p:nvPr/>
         </p:nvSpPr>
@@ -18947,7 +19172,7 @@
       </p:sp>
       <p:sp>
         <p:nvSpPr>
-          <p:cNvPr id="635" name="Google Shape;635;p29"/>
+          <p:cNvPr id="637" name="Google Shape;637;p29"/>
           <p:cNvSpPr/>
           <p:nvPr/>
         </p:nvSpPr>
@@ -19010,7 +19235,7 @@
       </p:sp>
       <p:sp>
         <p:nvSpPr>
-          <p:cNvPr id="636" name="Google Shape;636;p29"/>
+          <p:cNvPr id="638" name="Google Shape;638;p29"/>
           <p:cNvSpPr/>
           <p:nvPr/>
         </p:nvSpPr>
@@ -19073,7 +19298,7 @@
       </p:sp>
       <p:sp>
         <p:nvSpPr>
-          <p:cNvPr id="637" name="Google Shape;637;p29"/>
+          <p:cNvPr id="639" name="Google Shape;639;p29"/>
           <p:cNvSpPr/>
           <p:nvPr/>
         </p:nvSpPr>
@@ -19136,7 +19361,7 @@
       </p:sp>
       <p:sp>
         <p:nvSpPr>
-          <p:cNvPr id="638" name="Google Shape;638;p29"/>
+          <p:cNvPr id="640" name="Google Shape;640;p29"/>
           <p:cNvSpPr/>
           <p:nvPr/>
         </p:nvSpPr>
@@ -19199,7 +19424,7 @@
       </p:sp>
       <p:sp>
         <p:nvSpPr>
-          <p:cNvPr id="639" name="Google Shape;639;p29"/>
+          <p:cNvPr id="641" name="Google Shape;641;p29"/>
           <p:cNvSpPr/>
           <p:nvPr/>
         </p:nvSpPr>
@@ -19262,7 +19487,7 @@
       </p:sp>
       <p:sp>
         <p:nvSpPr>
-          <p:cNvPr id="640" name="Google Shape;640;p29"/>
+          <p:cNvPr id="642" name="Google Shape;642;p29"/>
           <p:cNvSpPr/>
           <p:nvPr/>
         </p:nvSpPr>
@@ -19325,7 +19550,7 @@
       </p:sp>
       <p:sp>
         <p:nvSpPr>
-          <p:cNvPr id="641" name="Google Shape;641;p29"/>
+          <p:cNvPr id="643" name="Google Shape;643;p29"/>
           <p:cNvSpPr/>
           <p:nvPr/>
         </p:nvSpPr>
@@ -19610,7 +19835,7 @@
           <a:effectLst>
             <a:outerShdw blurRad="50800" rotWithShape="0" algn="bl" dir="8100000" dist="25400">
               <a:srgbClr val="000000">
-                <a:alpha val="10200"/>
+                <a:alpha val="10199"/>
               </a:srgbClr>
             </a:outerShdw>
           </a:effectLst>
@@ -19892,7 +20117,7 @@
           <a:effectLst>
             <a:outerShdw blurRad="50800" rotWithShape="0" algn="bl" dir="8100000" dist="25400">
               <a:srgbClr val="000000">
-                <a:alpha val="10200"/>
+                <a:alpha val="10199"/>
               </a:srgbClr>
             </a:outerShdw>
           </a:effectLst>
@@ -20174,7 +20399,7 @@
           <a:effectLst>
             <a:outerShdw blurRad="50800" rotWithShape="0" algn="bl" dir="8100000" dist="25400">
               <a:srgbClr val="000000">
-                <a:alpha val="10200"/>
+                <a:alpha val="10199"/>
               </a:srgbClr>
             </a:outerShdw>
           </a:effectLst>
@@ -20456,7 +20681,7 @@
           <a:effectLst>
             <a:outerShdw blurRad="50800" rotWithShape="0" algn="bl" dir="8100000" dist="25400">
               <a:srgbClr val="000000">
-                <a:alpha val="10200"/>
+                <a:alpha val="10199"/>
               </a:srgbClr>
             </a:outerShdw>
           </a:effectLst>
@@ -20738,7 +20963,7 @@
           <a:effectLst>
             <a:outerShdw blurRad="50800" rotWithShape="0" algn="bl" dir="8100000" dist="25400">
               <a:srgbClr val="000000">
-                <a:alpha val="10200"/>
+                <a:alpha val="10199"/>
               </a:srgbClr>
             </a:outerShdw>
           </a:effectLst>
@@ -21211,7 +21436,7 @@
           <a:effectLst>
             <a:outerShdw blurRad="50800" rotWithShape="0" algn="bl" dir="8100000" dist="25400">
               <a:srgbClr val="000000">
-                <a:alpha val="10200"/>
+                <a:alpha val="10199"/>
               </a:srgbClr>
             </a:outerShdw>
           </a:effectLst>
@@ -31590,7 +31815,15 @@
                 <a:cs typeface="Arial"/>
                 <a:sym typeface="Arial"/>
               </a:rPr>
-              <a:t>Status: Government partnership, LOI in progress</a:t>
+              <a:t>Status: Government partnership, </a:t>
+            </a:r>
+            <a:r>
+              <a:rPr lang="en-US" sz="900">
+                <a:solidFill>
+                  <a:srgbClr val="4A5568"/>
+                </a:solidFill>
+              </a:rPr>
+              <a:t>MOU signed </a:t>
             </a:r>
             <a:endParaRPr b="0" i="0" sz="900" u="none" cap="none" strike="noStrike">
               <a:solidFill>
@@ -36798,6 +37031,285 @@
 </file>
 
 <file path=ppt/theme/theme1.xml><?xml version="1.0" encoding="utf-8"?>
+<a:theme xmlns:a="http://schemas.openxmlformats.org/drawingml/2006/main" xmlns:r="http://schemas.openxmlformats.org/officeDocument/2006/relationships" name="Office Theme">
+  <a:themeElements>
+    <a:clrScheme name="Office">
+      <a:dk1>
+        <a:srgbClr val="000000"/>
+      </a:dk1>
+      <a:lt1>
+        <a:srgbClr val="FFFFFF"/>
+      </a:lt1>
+      <a:dk2>
+        <a:srgbClr val="44546A"/>
+      </a:dk2>
+      <a:lt2>
+        <a:srgbClr val="E7E6E6"/>
+      </a:lt2>
+      <a:accent1>
+        <a:srgbClr val="4472C4"/>
+      </a:accent1>
+      <a:accent2>
+        <a:srgbClr val="ED7D31"/>
+      </a:accent2>
+      <a:accent3>
+        <a:srgbClr val="A5A5A5"/>
+      </a:accent3>
+      <a:accent4>
+        <a:srgbClr val="FFC000"/>
+      </a:accent4>
+      <a:accent5>
+        <a:srgbClr val="5B9BD5"/>
+      </a:accent5>
+      <a:accent6>
+        <a:srgbClr val="70AD47"/>
+      </a:accent6>
+      <a:hlink>
+        <a:srgbClr val="0563C1"/>
+      </a:hlink>
+      <a:folHlink>
+        <a:srgbClr val="954F72"/>
+      </a:folHlink>
+    </a:clrScheme>
+    <a:fontScheme name="Office">
+      <a:majorFont>
+        <a:latin typeface="Arial"/>
+        <a:ea typeface=""/>
+        <a:cs typeface=""/>
+        <a:font script="Jpan" typeface="ＭＳ Ｐゴシック"/>
+        <a:font script="Hang" typeface="맑은 고딕"/>
+        <a:font script="Hans" typeface="宋体"/>
+        <a:font script="Hant" typeface="新細明體"/>
+        <a:font script="Arab" typeface="Times New Roman"/>
+        <a:font script="Hebr" typeface="Times New Roman"/>
+        <a:font script="Thai" typeface="Angsana New"/>
+        <a:font script="Ethi" typeface="Nyala"/>
+        <a:font script="Beng" typeface="Vrinda"/>
+        <a:font script="Gujr" typeface="Shruti"/>
+        <a:font script="Khmr" typeface="MoolBoran"/>
+        <a:font script="Knda" typeface="Tunga"/>
+        <a:font script="Guru" typeface="Raavi"/>
+        <a:font script="Cans" typeface="Euphemia"/>
+        <a:font script="Cher" typeface="Plantagenet Cherokee"/>
+        <a:font script="Yiii" typeface="Microsoft Yi Baiti"/>
+        <a:font script="Tibt" typeface="Microsoft Himalaya"/>
+        <a:font script="Thaa" typeface="MV Boli"/>
+        <a:font script="Deva" typeface="Mangal"/>
+        <a:font script="Telu" typeface="Gautami"/>
+        <a:font script="Taml" typeface="Latha"/>
+        <a:font script="Syrc" typeface="Estrangelo Edessa"/>
+        <a:font script="Orya" typeface="Kalinga"/>
+        <a:font script="Mlym" typeface="Kartika"/>
+        <a:font script="Laoo" typeface="DokChampa"/>
+        <a:font script="Sinh" typeface="Iskoola Pota"/>
+        <a:font script="Mong" typeface="Mongolian Baiti"/>
+        <a:font script="Viet" typeface="Times New Roman"/>
+        <a:font script="Uigh" typeface="Microsoft Uighur"/>
+        <a:font script="Geor" typeface="Sylfaen"/>
+      </a:majorFont>
+      <a:minorFont>
+        <a:latin typeface="Arial"/>
+        <a:ea typeface=""/>
+        <a:cs typeface=""/>
+        <a:font script="Jpan" typeface="ＭＳ Ｐゴシック"/>
+        <a:font script="Hang" typeface="맑은 고딕"/>
+        <a:font script="Hans" typeface="宋体"/>
+        <a:font script="Hant" typeface="新細明體"/>
+        <a:font script="Arab" typeface="Arial"/>
+        <a:font script="Hebr" typeface="Arial"/>
+        <a:font script="Thai" typeface="Cordia New"/>
+        <a:font script="Ethi" typeface="Nyala"/>
+        <a:font script="Beng" typeface="Vrinda"/>
+        <a:font script="Gujr" typeface="Shruti"/>
+        <a:font script="Khmr" typeface="DaunPenh"/>
+        <a:font script="Knda" typeface="Tunga"/>
+        <a:font script="Guru" typeface="Raavi"/>
+        <a:font script="Cans" typeface="Euphemia"/>
+        <a:font script="Cher" typeface="Plantagenet Cherokee"/>
+        <a:font script="Yiii" typeface="Microsoft Yi Baiti"/>
+        <a:font script="Tibt" typeface="Microsoft Himalaya"/>
+        <a:font script="Thaa" typeface="MV Boli"/>
+        <a:font script="Deva" typeface="Mangal"/>
+        <a:font script="Telu" typeface="Gautami"/>
+        <a:font script="Taml" typeface="Latha"/>
+        <a:font script="Syrc" typeface="Estrangelo Edessa"/>
+        <a:font script="Orya" typeface="Kalinga"/>
+        <a:font script="Mlym" typeface="Kartika"/>
+        <a:font script="Laoo" typeface="DokChampa"/>
+        <a:font script="Sinh" typeface="Iskoola Pota"/>
+        <a:font script="Mong" typeface="Mongolian Baiti"/>
+        <a:font script="Viet" typeface="Arial"/>
+        <a:font script="Uigh" typeface="Microsoft Uighur"/>
+        <a:font script="Geor" typeface="Sylfaen"/>
+      </a:minorFont>
+    </a:fontScheme>
+    <a:fmtScheme name="Office">
+      <a:fillStyleLst>
+        <a:solidFill>
+          <a:schemeClr val="phClr"/>
+        </a:solidFill>
+        <a:gradFill rotWithShape="1">
+          <a:gsLst>
+            <a:gs pos="0">
+              <a:schemeClr val="phClr">
+                <a:tint val="50000"/>
+                <a:satMod val="300000"/>
+              </a:schemeClr>
+            </a:gs>
+            <a:gs pos="35000">
+              <a:schemeClr val="phClr">
+                <a:tint val="37000"/>
+                <a:satMod val="300000"/>
+              </a:schemeClr>
+            </a:gs>
+            <a:gs pos="100000">
+              <a:schemeClr val="phClr">
+                <a:tint val="15000"/>
+                <a:satMod val="350000"/>
+              </a:schemeClr>
+            </a:gs>
+          </a:gsLst>
+          <a:lin ang="16200000" scaled="1"/>
+        </a:gradFill>
+        <a:gradFill rotWithShape="1">
+          <a:gsLst>
+            <a:gs pos="0">
+              <a:schemeClr val="phClr">
+                <a:tint val="100000"/>
+                <a:shade val="100000"/>
+                <a:satMod val="130000"/>
+              </a:schemeClr>
+            </a:gs>
+            <a:gs pos="100000">
+              <a:schemeClr val="phClr">
+                <a:tint val="50000"/>
+                <a:shade val="100000"/>
+                <a:satMod val="350000"/>
+              </a:schemeClr>
+            </a:gs>
+          </a:gsLst>
+          <a:lin ang="16200000" scaled="0"/>
+        </a:gradFill>
+      </a:fillStyleLst>
+      <a:lnStyleLst>
+        <a:ln w="9525" cap="flat" cmpd="sng" algn="ctr">
+          <a:solidFill>
+            <a:schemeClr val="phClr">
+              <a:shade val="95000"/>
+              <a:satMod val="105000"/>
+            </a:schemeClr>
+          </a:solidFill>
+          <a:prstDash val="solid"/>
+        </a:ln>
+        <a:ln w="25400" cap="flat" cmpd="sng" algn="ctr">
+          <a:solidFill>
+            <a:schemeClr val="phClr"/>
+          </a:solidFill>
+          <a:prstDash val="solid"/>
+        </a:ln>
+        <a:ln w="38100" cap="flat" cmpd="sng" algn="ctr">
+          <a:solidFill>
+            <a:schemeClr val="phClr"/>
+          </a:solidFill>
+          <a:prstDash val="solid"/>
+        </a:ln>
+      </a:lnStyleLst>
+      <a:effectStyleLst>
+        <a:effectStyle>
+          <a:effectLst>
+            <a:outerShdw blurRad="40000" dist="20000" dir="5400000" rotWithShape="0">
+              <a:srgbClr val="000000">
+                <a:alpha val="38000"/>
+              </a:srgbClr>
+            </a:outerShdw>
+          </a:effectLst>
+        </a:effectStyle>
+        <a:effectStyle>
+          <a:effectLst>
+            <a:outerShdw blurRad="40000" dist="23000" dir="5400000" rotWithShape="0">
+              <a:srgbClr val="000000">
+                <a:alpha val="35000"/>
+              </a:srgbClr>
+            </a:outerShdw>
+          </a:effectLst>
+        </a:effectStyle>
+        <a:effectStyle>
+          <a:effectLst>
+            <a:outerShdw blurRad="40000" dist="23000" dir="5400000" rotWithShape="0">
+              <a:srgbClr val="000000">
+                <a:alpha val="35000"/>
+              </a:srgbClr>
+            </a:outerShdw>
+          </a:effectLst>
+          <a:scene3d>
+            <a:camera prst="orthographicFront">
+              <a:rot lat="0" lon="0" rev="0"/>
+            </a:camera>
+            <a:lightRig rig="threePt" dir="t">
+              <a:rot lat="0" lon="0" rev="1200000"/>
+            </a:lightRig>
+          </a:scene3d>
+          <a:sp3d>
+            <a:bevelT w="63500" h="25400"/>
+          </a:sp3d>
+        </a:effectStyle>
+      </a:effectStyleLst>
+      <a:bgFillStyleLst>
+        <a:solidFill>
+          <a:schemeClr val="phClr"/>
+        </a:solidFill>
+        <a:gradFill rotWithShape="1">
+          <a:gsLst>
+            <a:gs pos="0">
+              <a:schemeClr val="phClr">
+                <a:tint val="40000"/>
+                <a:satMod val="350000"/>
+              </a:schemeClr>
+            </a:gs>
+            <a:gs pos="40000">
+              <a:schemeClr val="phClr">
+                <a:tint val="45000"/>
+                <a:shade val="99000"/>
+                <a:satMod val="350000"/>
+              </a:schemeClr>
+            </a:gs>
+            <a:gs pos="100000">
+              <a:schemeClr val="phClr">
+                <a:shade val="20000"/>
+                <a:satMod val="255000"/>
+              </a:schemeClr>
+            </a:gs>
+          </a:gsLst>
+          <a:path path="circle">
+            <a:fillToRect l="50000" t="-80000" r="50000" b="180000"/>
+          </a:path>
+        </a:gradFill>
+        <a:gradFill rotWithShape="1">
+          <a:gsLst>
+            <a:gs pos="0">
+              <a:schemeClr val="phClr">
+                <a:tint val="80000"/>
+                <a:satMod val="300000"/>
+              </a:schemeClr>
+            </a:gs>
+            <a:gs pos="100000">
+              <a:schemeClr val="phClr">
+                <a:shade val="30000"/>
+                <a:satMod val="200000"/>
+              </a:schemeClr>
+            </a:gs>
+          </a:gsLst>
+          <a:path path="circle">
+            <a:fillToRect l="50000" t="50000" r="50000" b="50000"/>
+          </a:path>
+        </a:gradFill>
+      </a:bgFillStyleLst>
+    </a:fmtScheme>
+  </a:themeElements>
+</a:theme>
+</file>
+
+<file path=ppt/theme/theme2.xml><?xml version="1.0" encoding="utf-8"?>
 <a:theme xmlns:a="http://schemas.openxmlformats.org/drawingml/2006/main" xmlns:r="http://schemas.openxmlformats.org/officeDocument/2006/relationships" name="Simple Light">
   <a:themeElements>
     <a:clrScheme name="Simple Light">
@@ -37074,283 +37586,4 @@
     </a:fmtScheme>
   </a:themeElements>
 </a:theme>
-</file>
-
-<file path=ppt/theme/theme2.xml><?xml version="1.0" encoding="utf-8"?>
-<a:theme xmlns:a="http://schemas.openxmlformats.org/drawingml/2006/main" xmlns:r="http://schemas.openxmlformats.org/officeDocument/2006/relationships" name="Office Theme">
-  <a:themeElements>
-    <a:clrScheme name="Office">
-      <a:dk1>
-        <a:srgbClr val="000000"/>
-      </a:dk1>
-      <a:lt1>
-        <a:srgbClr val="FFFFFF"/>
-      </a:lt1>
-      <a:dk2>
-        <a:srgbClr val="44546A"/>
-      </a:dk2>
-      <a:lt2>
-        <a:srgbClr val="E7E6E6"/>
-      </a:lt2>
-      <a:accent1>
-        <a:srgbClr val="4472C4"/>
-      </a:accent1>
-      <a:accent2>
-        <a:srgbClr val="ED7D31"/>
-      </a:accent2>
-      <a:accent3>
-        <a:srgbClr val="A5A5A5"/>
-      </a:accent3>
-      <a:accent4>
-        <a:srgbClr val="FFC000"/>
-      </a:accent4>
-      <a:accent5>
-        <a:srgbClr val="5B9BD5"/>
-      </a:accent5>
-      <a:accent6>
-        <a:srgbClr val="70AD47"/>
-      </a:accent6>
-      <a:hlink>
-        <a:srgbClr val="0563C1"/>
-      </a:hlink>
-      <a:folHlink>
-        <a:srgbClr val="954F72"/>
-      </a:folHlink>
-    </a:clrScheme>
-    <a:fontScheme name="Office">
-      <a:majorFont>
-        <a:latin typeface="Arial"/>
-        <a:ea typeface=""/>
-        <a:cs typeface=""/>
-        <a:font script="Jpan" typeface="ＭＳ Ｐゴシック"/>
-        <a:font script="Hang" typeface="맑은 고딕"/>
-        <a:font script="Hans" typeface="宋体"/>
-        <a:font script="Hant" typeface="新細明體"/>
-        <a:font script="Arab" typeface="Times New Roman"/>
-        <a:font script="Hebr" typeface="Times New Roman"/>
-        <a:font script="Thai" typeface="Angsana New"/>
-        <a:font script="Ethi" typeface="Nyala"/>
-        <a:font script="Beng" typeface="Vrinda"/>
-        <a:font script="Gujr" typeface="Shruti"/>
-        <a:font script="Khmr" typeface="MoolBoran"/>
-        <a:font script="Knda" typeface="Tunga"/>
-        <a:font script="Guru" typeface="Raavi"/>
-        <a:font script="Cans" typeface="Euphemia"/>
-        <a:font script="Cher" typeface="Plantagenet Cherokee"/>
-        <a:font script="Yiii" typeface="Microsoft Yi Baiti"/>
-        <a:font script="Tibt" typeface="Microsoft Himalaya"/>
-        <a:font script="Thaa" typeface="MV Boli"/>
-        <a:font script="Deva" typeface="Mangal"/>
-        <a:font script="Telu" typeface="Gautami"/>
-        <a:font script="Taml" typeface="Latha"/>
-        <a:font script="Syrc" typeface="Estrangelo Edessa"/>
-        <a:font script="Orya" typeface="Kalinga"/>
-        <a:font script="Mlym" typeface="Kartika"/>
-        <a:font script="Laoo" typeface="DokChampa"/>
-        <a:font script="Sinh" typeface="Iskoola Pota"/>
-        <a:font script="Mong" typeface="Mongolian Baiti"/>
-        <a:font script="Viet" typeface="Times New Roman"/>
-        <a:font script="Uigh" typeface="Microsoft Uighur"/>
-        <a:font script="Geor" typeface="Sylfaen"/>
-      </a:majorFont>
-      <a:minorFont>
-        <a:latin typeface="Arial"/>
-        <a:ea typeface=""/>
-        <a:cs typeface=""/>
-        <a:font script="Jpan" typeface="ＭＳ Ｐゴシック"/>
-        <a:font script="Hang" typeface="맑은 고딕"/>
-        <a:font script="Hans" typeface="宋体"/>
-        <a:font script="Hant" typeface="新細明體"/>
-        <a:font script="Arab" typeface="Arial"/>
-        <a:font script="Hebr" typeface="Arial"/>
-        <a:font script="Thai" typeface="Cordia New"/>
-        <a:font script="Ethi" typeface="Nyala"/>
-        <a:font script="Beng" typeface="Vrinda"/>
-        <a:font script="Gujr" typeface="Shruti"/>
-        <a:font script="Khmr" typeface="DaunPenh"/>
-        <a:font script="Knda" typeface="Tunga"/>
-        <a:font script="Guru" typeface="Raavi"/>
-        <a:font script="Cans" typeface="Euphemia"/>
-        <a:font script="Cher" typeface="Plantagenet Cherokee"/>
-        <a:font script="Yiii" typeface="Microsoft Yi Baiti"/>
-        <a:font script="Tibt" typeface="Microsoft Himalaya"/>
-        <a:font script="Thaa" typeface="MV Boli"/>
-        <a:font script="Deva" typeface="Mangal"/>
-        <a:font script="Telu" typeface="Gautami"/>
-        <a:font script="Taml" typeface="Latha"/>
-        <a:font script="Syrc" typeface="Estrangelo Edessa"/>
-        <a:font script="Orya" typeface="Kalinga"/>
-        <a:font script="Mlym" typeface="Kartika"/>
-        <a:font script="Laoo" typeface="DokChampa"/>
-        <a:font script="Sinh" typeface="Iskoola Pota"/>
-        <a:font script="Mong" typeface="Mongolian Baiti"/>
-        <a:font script="Viet" typeface="Arial"/>
-        <a:font script="Uigh" typeface="Microsoft Uighur"/>
-        <a:font script="Geor" typeface="Sylfaen"/>
-      </a:minorFont>
-    </a:fontScheme>
-    <a:fmtScheme name="Office">
-      <a:fillStyleLst>
-        <a:solidFill>
-          <a:schemeClr val="phClr"/>
-        </a:solidFill>
-        <a:gradFill rotWithShape="1">
-          <a:gsLst>
-            <a:gs pos="0">
-              <a:schemeClr val="phClr">
-                <a:tint val="50000"/>
-                <a:satMod val="300000"/>
-              </a:schemeClr>
-            </a:gs>
-            <a:gs pos="35000">
-              <a:schemeClr val="phClr">
-                <a:tint val="37000"/>
-                <a:satMod val="300000"/>
-              </a:schemeClr>
-            </a:gs>
-            <a:gs pos="100000">
-              <a:schemeClr val="phClr">
-                <a:tint val="15000"/>
-                <a:satMod val="350000"/>
-              </a:schemeClr>
-            </a:gs>
-          </a:gsLst>
-          <a:lin ang="16200000" scaled="1"/>
-        </a:gradFill>
-        <a:gradFill rotWithShape="1">
-          <a:gsLst>
-            <a:gs pos="0">
-              <a:schemeClr val="phClr">
-                <a:tint val="100000"/>
-                <a:shade val="100000"/>
-                <a:satMod val="130000"/>
-              </a:schemeClr>
-            </a:gs>
-            <a:gs pos="100000">
-              <a:schemeClr val="phClr">
-                <a:tint val="50000"/>
-                <a:shade val="100000"/>
-                <a:satMod val="350000"/>
-              </a:schemeClr>
-            </a:gs>
-          </a:gsLst>
-          <a:lin ang="16200000" scaled="0"/>
-        </a:gradFill>
-      </a:fillStyleLst>
-      <a:lnStyleLst>
-        <a:ln w="9525" cap="flat" cmpd="sng" algn="ctr">
-          <a:solidFill>
-            <a:schemeClr val="phClr">
-              <a:shade val="95000"/>
-              <a:satMod val="105000"/>
-            </a:schemeClr>
-          </a:solidFill>
-          <a:prstDash val="solid"/>
-        </a:ln>
-        <a:ln w="25400" cap="flat" cmpd="sng" algn="ctr">
-          <a:solidFill>
-            <a:schemeClr val="phClr"/>
-          </a:solidFill>
-          <a:prstDash val="solid"/>
-        </a:ln>
-        <a:ln w="38100" cap="flat" cmpd="sng" algn="ctr">
-          <a:solidFill>
-            <a:schemeClr val="phClr"/>
-          </a:solidFill>
-          <a:prstDash val="solid"/>
-        </a:ln>
-      </a:lnStyleLst>
-      <a:effectStyleLst>
-        <a:effectStyle>
-          <a:effectLst>
-            <a:outerShdw blurRad="40000" dist="20000" dir="5400000" rotWithShape="0">
-              <a:srgbClr val="000000">
-                <a:alpha val="38000"/>
-              </a:srgbClr>
-            </a:outerShdw>
-          </a:effectLst>
-        </a:effectStyle>
-        <a:effectStyle>
-          <a:effectLst>
-            <a:outerShdw blurRad="40000" dist="23000" dir="5400000" rotWithShape="0">
-              <a:srgbClr val="000000">
-                <a:alpha val="35000"/>
-              </a:srgbClr>
-            </a:outerShdw>
-          </a:effectLst>
-        </a:effectStyle>
-        <a:effectStyle>
-          <a:effectLst>
-            <a:outerShdw blurRad="40000" dist="23000" dir="5400000" rotWithShape="0">
-              <a:srgbClr val="000000">
-                <a:alpha val="35000"/>
-              </a:srgbClr>
-            </a:outerShdw>
-          </a:effectLst>
-          <a:scene3d>
-            <a:camera prst="orthographicFront">
-              <a:rot lat="0" lon="0" rev="0"/>
-            </a:camera>
-            <a:lightRig rig="threePt" dir="t">
-              <a:rot lat="0" lon="0" rev="1200000"/>
-            </a:lightRig>
-          </a:scene3d>
-          <a:sp3d>
-            <a:bevelT w="63500" h="25400"/>
-          </a:sp3d>
-        </a:effectStyle>
-      </a:effectStyleLst>
-      <a:bgFillStyleLst>
-        <a:solidFill>
-          <a:schemeClr val="phClr"/>
-        </a:solidFill>
-        <a:gradFill rotWithShape="1">
-          <a:gsLst>
-            <a:gs pos="0">
-              <a:schemeClr val="phClr">
-                <a:tint val="40000"/>
-                <a:satMod val="350000"/>
-              </a:schemeClr>
-            </a:gs>
-            <a:gs pos="40000">
-              <a:schemeClr val="phClr">
-                <a:tint val="45000"/>
-                <a:shade val="99000"/>
-                <a:satMod val="350000"/>
-              </a:schemeClr>
-            </a:gs>
-            <a:gs pos="100000">
-              <a:schemeClr val="phClr">
-                <a:shade val="20000"/>
-                <a:satMod val="255000"/>
-              </a:schemeClr>
-            </a:gs>
-          </a:gsLst>
-          <a:path path="circle">
-            <a:fillToRect l="50000" t="-80000" r="50000" b="180000"/>
-          </a:path>
-        </a:gradFill>
-        <a:gradFill rotWithShape="1">
-          <a:gsLst>
-            <a:gs pos="0">
-              <a:schemeClr val="phClr">
-                <a:tint val="80000"/>
-                <a:satMod val="300000"/>
-              </a:schemeClr>
-            </a:gs>
-            <a:gs pos="100000">
-              <a:schemeClr val="phClr">
-                <a:shade val="30000"/>
-                <a:satMod val="200000"/>
-              </a:schemeClr>
-            </a:gs>
-          </a:gsLst>
-          <a:path path="circle">
-            <a:fillToRect l="50000" t="50000" r="50000" b="50000"/>
-          </a:path>
-        </a:gradFill>
-      </a:bgFillStyleLst>
-    </a:fmtScheme>
-  </a:themeElements>
-</a:theme>
 </file>
</xml_diff>